<commit_message>
Organize hardware folders, rename IOCTRL, and add bracket and Ethernet references
</commit_message>
<xml_diff>
--- a/.work/r24/candidate.pptx
+++ b/.work/r24/candidate.pptx
@@ -2,26 +2,26 @@
 <file path=ppt/presentation.xml><?xml version="1.0" encoding="utf-8"?>
 <p:presentation xmlns:p="http://schemas.openxmlformats.org/presentationml/2006/main">
   <p:sldMasterIdLst>
-    <p:sldMasterId xmlns:r="http://schemas.openxmlformats.org/officeDocument/2006/relationships" id="2147483648" r:id="Rd3a5054650a44271"/>
+    <p:sldMasterId xmlns:r="http://schemas.openxmlformats.org/officeDocument/2006/relationships" id="2147483648" r:id="R110421cc4c294886"/>
   </p:sldMasterIdLst>
   <p:notesMasterIdLst>
-    <p:notesMasterId xmlns:r="http://schemas.openxmlformats.org/officeDocument/2006/relationships" r:id="R108aafdb37c743ef"/>
+    <p:notesMasterId xmlns:r="http://schemas.openxmlformats.org/officeDocument/2006/relationships" r:id="Rde7a0fd987a543ad"/>
   </p:notesMasterIdLst>
   <p:sldIdLst>
-    <p:sldId xmlns:r="http://schemas.openxmlformats.org/officeDocument/2006/relationships" id="256" r:id="R51234ceedb4443a0"/>
-    <p:sldId xmlns:r="http://schemas.openxmlformats.org/officeDocument/2006/relationships" id="257" r:id="Rd19b61e17c874831"/>
-    <p:sldId xmlns:r="http://schemas.openxmlformats.org/officeDocument/2006/relationships" id="258" r:id="R6d716502525d452b"/>
-    <p:sldId xmlns:r="http://schemas.openxmlformats.org/officeDocument/2006/relationships" id="259" r:id="R7bec4d26713449e4"/>
-    <p:sldId xmlns:r="http://schemas.openxmlformats.org/officeDocument/2006/relationships" id="260" r:id="R3680b98475104d38"/>
-    <p:sldId xmlns:r="http://schemas.openxmlformats.org/officeDocument/2006/relationships" id="261" r:id="Rdc314e6cb4f04b2d"/>
-    <p:sldId xmlns:r="http://schemas.openxmlformats.org/officeDocument/2006/relationships" id="262" r:id="R44848717f714490f"/>
-    <p:sldId xmlns:r="http://schemas.openxmlformats.org/officeDocument/2006/relationships" id="263" r:id="R3920c683785e41b2"/>
-    <p:sldId xmlns:r="http://schemas.openxmlformats.org/officeDocument/2006/relationships" id="264" r:id="Rbc0d1152529849ff"/>
-    <p:sldId xmlns:r="http://schemas.openxmlformats.org/officeDocument/2006/relationships" id="265" r:id="Re21d809e39fe4780"/>
-    <p:sldId xmlns:r="http://schemas.openxmlformats.org/officeDocument/2006/relationships" id="266" r:id="R072906e2eab94639"/>
-    <p:sldId xmlns:r="http://schemas.openxmlformats.org/officeDocument/2006/relationships" id="267" r:id="R148ebe9494b04ffa"/>
-    <p:sldId xmlns:r="http://schemas.openxmlformats.org/officeDocument/2006/relationships" id="268" r:id="R9d986b01effb4c91"/>
-    <p:sldId xmlns:r="http://schemas.openxmlformats.org/officeDocument/2006/relationships" id="269" r:id="Ra9825ba359ef426c"/>
+    <p:sldId xmlns:r="http://schemas.openxmlformats.org/officeDocument/2006/relationships" id="256" r:id="R3793028934564c39"/>
+    <p:sldId xmlns:r="http://schemas.openxmlformats.org/officeDocument/2006/relationships" id="257" r:id="R7786f2adc01f4ff2"/>
+    <p:sldId xmlns:r="http://schemas.openxmlformats.org/officeDocument/2006/relationships" id="258" r:id="R361e45613e634269"/>
+    <p:sldId xmlns:r="http://schemas.openxmlformats.org/officeDocument/2006/relationships" id="259" r:id="R3239eada29e64ae7"/>
+    <p:sldId xmlns:r="http://schemas.openxmlformats.org/officeDocument/2006/relationships" id="260" r:id="R4243d01da984458e"/>
+    <p:sldId xmlns:r="http://schemas.openxmlformats.org/officeDocument/2006/relationships" id="261" r:id="Re174f6dc02f442d6"/>
+    <p:sldId xmlns:r="http://schemas.openxmlformats.org/officeDocument/2006/relationships" id="262" r:id="Rf4dc1d60dc874b50"/>
+    <p:sldId xmlns:r="http://schemas.openxmlformats.org/officeDocument/2006/relationships" id="263" r:id="Rf070c4f7bcaf4ab0"/>
+    <p:sldId xmlns:r="http://schemas.openxmlformats.org/officeDocument/2006/relationships" id="264" r:id="R7bcd3b90dcb74eb7"/>
+    <p:sldId xmlns:r="http://schemas.openxmlformats.org/officeDocument/2006/relationships" id="265" r:id="Rae0c7ada6ac04c12"/>
+    <p:sldId xmlns:r="http://schemas.openxmlformats.org/officeDocument/2006/relationships" id="266" r:id="R9a80440194ee4d13"/>
+    <p:sldId xmlns:r="http://schemas.openxmlformats.org/officeDocument/2006/relationships" id="267" r:id="Rb693439af80345f4"/>
+    <p:sldId xmlns:r="http://schemas.openxmlformats.org/officeDocument/2006/relationships" id="268" r:id="Rf6ce738a9d4a4f4f"/>
+    <p:sldId xmlns:r="http://schemas.openxmlformats.org/officeDocument/2006/relationships" id="269" r:id="Rd109a30048754d07"/>
   </p:sldIdLst>
   <p:sldSz cx="12192000" cy="6858000"/>
   <p:notesSz cx="6858000" cy="9144000"/>
@@ -1487,7 +1487,7 @@
   </p:cSld>
   <p:clrMap bg1="lt1" tx1="dk1" bg2="lt2" tx2="dk2" accent1="accent1" accent2="accent2" accent3="accent3" accent4="accent4" accent5="accent5" accent6="accent6" hlink="hlink" folHlink="folHlink"/>
   <p:sldLayoutIdLst>
-    <p:sldLayoutId xmlns:r="http://schemas.openxmlformats.org/officeDocument/2006/relationships" id="2147483649" r:id="R1a404739be9a478c"/>
+    <p:sldLayoutId xmlns:r="http://schemas.openxmlformats.org/officeDocument/2006/relationships" id="2147483649" r:id="Rca99b149c4f34792"/>
   </p:sldLayoutIdLst>
   <p:hf sldNum="0" hdr="0" ftr="0" dt="0"/>
   <p:txStyles>
@@ -2417,7 +2417,7 @@
           <p:nvPr/>
         </p:nvPicPr>
         <p:blipFill>
-          <a:blip xmlns:r="http://schemas.openxmlformats.org/officeDocument/2006/relationships" xmlns:a="http://schemas.openxmlformats.org/drawingml/2006/main" r:embed="R2c0636150ff64f28"/>
+          <a:blip xmlns:r="http://schemas.openxmlformats.org/officeDocument/2006/relationships" xmlns:a="http://schemas.openxmlformats.org/drawingml/2006/main" r:embed="Ra1e3ad76f0ce4810"/>
           <a:stretch xmlns:a="http://schemas.openxmlformats.org/drawingml/2006/main">
             <a:fillRect l="0" t="0" r="0" b="0"/>
           </a:stretch>
@@ -2533,7 +2533,7 @@
           <p:nvPr/>
         </p:nvPicPr>
         <p:blipFill>
-          <a:blip xmlns:r="http://schemas.openxmlformats.org/officeDocument/2006/relationships" xmlns:a="http://schemas.openxmlformats.org/drawingml/2006/main" r:embed="R6e8deca3096846de"/>
+          <a:blip xmlns:r="http://schemas.openxmlformats.org/officeDocument/2006/relationships" xmlns:a="http://schemas.openxmlformats.org/drawingml/2006/main" r:embed="R84d8c95631c64923"/>
           <a:stretch xmlns:a="http://schemas.openxmlformats.org/drawingml/2006/main">
             <a:fillRect l="0" t="0" r="0" b="0"/>
           </a:stretch>
@@ -2763,7 +2763,7 @@
           <p:nvPr/>
         </p:nvPicPr>
         <p:blipFill>
-          <a:blip xmlns:r="http://schemas.openxmlformats.org/officeDocument/2006/relationships" xmlns:a="http://schemas.openxmlformats.org/drawingml/2006/main" r:embed="R4ac6e1792b014874"/>
+          <a:blip xmlns:r="http://schemas.openxmlformats.org/officeDocument/2006/relationships" xmlns:a="http://schemas.openxmlformats.org/drawingml/2006/main" r:embed="R06ae71dab1ef4147"/>
           <a:stretch xmlns:a="http://schemas.openxmlformats.org/drawingml/2006/main">
             <a:fillRect l="0" t="0" r="0" b="0"/>
           </a:stretch>
@@ -3150,7 +3150,7 @@
           <p:nvPr/>
         </p:nvPicPr>
         <p:blipFill>
-          <a:blip xmlns:r="http://schemas.openxmlformats.org/officeDocument/2006/relationships" xmlns:a="http://schemas.openxmlformats.org/drawingml/2006/main" r:embed="Rd478cba0585b4363"/>
+          <a:blip xmlns:r="http://schemas.openxmlformats.org/officeDocument/2006/relationships" xmlns:a="http://schemas.openxmlformats.org/drawingml/2006/main" r:embed="R2679c3d760814065"/>
           <a:stretch xmlns:a="http://schemas.openxmlformats.org/drawingml/2006/main">
             <a:fillRect l="0" t="0" r="0" b="0"/>
           </a:stretch>
@@ -3266,7 +3266,7 @@
           <p:nvPr/>
         </p:nvPicPr>
         <p:blipFill>
-          <a:blip xmlns:r="http://schemas.openxmlformats.org/officeDocument/2006/relationships" xmlns:a="http://schemas.openxmlformats.org/drawingml/2006/main" r:embed="Recd0652defc44147"/>
+          <a:blip xmlns:r="http://schemas.openxmlformats.org/officeDocument/2006/relationships" xmlns:a="http://schemas.openxmlformats.org/drawingml/2006/main" r:embed="Rb00e9b915c7f481b"/>
           <a:stretch xmlns:a="http://schemas.openxmlformats.org/drawingml/2006/main">
             <a:fillRect l="0" t="0" r="0" b="0"/>
           </a:stretch>
@@ -3496,7 +3496,7 @@
           <p:nvPr/>
         </p:nvPicPr>
         <p:blipFill>
-          <a:blip xmlns:r="http://schemas.openxmlformats.org/officeDocument/2006/relationships" xmlns:a="http://schemas.openxmlformats.org/drawingml/2006/main" r:embed="R8f904354031e43b2"/>
+          <a:blip xmlns:r="http://schemas.openxmlformats.org/officeDocument/2006/relationships" xmlns:a="http://schemas.openxmlformats.org/drawingml/2006/main" r:embed="R92cddc44a8e94d0e"/>
           <a:stretch xmlns:a="http://schemas.openxmlformats.org/drawingml/2006/main">
             <a:fillRect l="0" t="0" r="0" b="0"/>
           </a:stretch>
@@ -3883,7 +3883,7 @@
           <p:nvPr/>
         </p:nvPicPr>
         <p:blipFill>
-          <a:blip xmlns:r="http://schemas.openxmlformats.org/officeDocument/2006/relationships" xmlns:a="http://schemas.openxmlformats.org/drawingml/2006/main" r:embed="R8d93e0314e754904"/>
+          <a:blip xmlns:r="http://schemas.openxmlformats.org/officeDocument/2006/relationships" xmlns:a="http://schemas.openxmlformats.org/drawingml/2006/main" r:embed="R40b29ed2fbe34e6e"/>
           <a:stretch xmlns:a="http://schemas.openxmlformats.org/drawingml/2006/main">
             <a:fillRect l="0" t="0" r="0" b="0"/>
           </a:stretch>
@@ -3999,7 +3999,7 @@
           <p:nvPr/>
         </p:nvPicPr>
         <p:blipFill>
-          <a:blip xmlns:r="http://schemas.openxmlformats.org/officeDocument/2006/relationships" xmlns:a="http://schemas.openxmlformats.org/drawingml/2006/main" r:embed="R0f2b43123c1143c4"/>
+          <a:blip xmlns:r="http://schemas.openxmlformats.org/officeDocument/2006/relationships" xmlns:a="http://schemas.openxmlformats.org/drawingml/2006/main" r:embed="Rc48b6a9dbeef4caf"/>
           <a:stretch xmlns:a="http://schemas.openxmlformats.org/drawingml/2006/main">
             <a:fillRect l="0" t="0" r="0" b="0"/>
           </a:stretch>
@@ -4229,7 +4229,7 @@
           <p:nvPr/>
         </p:nvPicPr>
         <p:blipFill>
-          <a:blip xmlns:r="http://schemas.openxmlformats.org/officeDocument/2006/relationships" xmlns:a="http://schemas.openxmlformats.org/drawingml/2006/main" r:embed="R7d78bb40fd1648ec"/>
+          <a:blip xmlns:r="http://schemas.openxmlformats.org/officeDocument/2006/relationships" xmlns:a="http://schemas.openxmlformats.org/drawingml/2006/main" r:embed="R780b6a3cff5e45a9"/>
           <a:stretch xmlns:a="http://schemas.openxmlformats.org/drawingml/2006/main">
             <a:fillRect l="0" t="0" r="0" b="0"/>
           </a:stretch>
@@ -4616,7 +4616,7 @@
           <p:nvPr/>
         </p:nvPicPr>
         <p:blipFill>
-          <a:blip xmlns:r="http://schemas.openxmlformats.org/officeDocument/2006/relationships" xmlns:a="http://schemas.openxmlformats.org/drawingml/2006/main" r:embed="Rc88b3036736c477b"/>
+          <a:blip xmlns:r="http://schemas.openxmlformats.org/officeDocument/2006/relationships" xmlns:a="http://schemas.openxmlformats.org/drawingml/2006/main" r:embed="R30683c8593d140a5"/>
           <a:stretch xmlns:a="http://schemas.openxmlformats.org/drawingml/2006/main">
             <a:fillRect l="0" t="0" r="0" b="0"/>
           </a:stretch>
@@ -4732,7 +4732,7 @@
           <p:nvPr/>
         </p:nvPicPr>
         <p:blipFill>
-          <a:blip xmlns:r="http://schemas.openxmlformats.org/officeDocument/2006/relationships" xmlns:a="http://schemas.openxmlformats.org/drawingml/2006/main" r:embed="R0a21ad075d704700"/>
+          <a:blip xmlns:r="http://schemas.openxmlformats.org/officeDocument/2006/relationships" xmlns:a="http://schemas.openxmlformats.org/drawingml/2006/main" r:embed="Rff9765460cd249c0"/>
           <a:stretch xmlns:a="http://schemas.openxmlformats.org/drawingml/2006/main">
             <a:fillRect l="0" t="0" r="0" b="0"/>
           </a:stretch>
@@ -4962,7 +4962,7 @@
           <p:nvPr/>
         </p:nvPicPr>
         <p:blipFill>
-          <a:blip xmlns:r="http://schemas.openxmlformats.org/officeDocument/2006/relationships" xmlns:a="http://schemas.openxmlformats.org/drawingml/2006/main" r:embed="R14db2924c8a34f25"/>
+          <a:blip xmlns:r="http://schemas.openxmlformats.org/officeDocument/2006/relationships" xmlns:a="http://schemas.openxmlformats.org/drawingml/2006/main" r:embed="Ra9ab250f76044057"/>
           <a:stretch xmlns:a="http://schemas.openxmlformats.org/drawingml/2006/main">
             <a:fillRect l="0" t="0" r="0" b="0"/>
           </a:stretch>
@@ -5428,7 +5428,7 @@
           <p:nvPr/>
         </p:nvPicPr>
         <p:blipFill>
-          <a:blip xmlns:r="http://schemas.openxmlformats.org/officeDocument/2006/relationships" xmlns:a="http://schemas.openxmlformats.org/drawingml/2006/main" r:embed="R7e52fe6d9ae04621"/>
+          <a:blip xmlns:r="http://schemas.openxmlformats.org/officeDocument/2006/relationships" xmlns:a="http://schemas.openxmlformats.org/drawingml/2006/main" r:embed="R9dbffa86fba64c20"/>
           <a:stretch xmlns:a="http://schemas.openxmlformats.org/drawingml/2006/main">
             <a:fillRect l="0" t="0" r="0" b="0"/>
           </a:stretch>
@@ -5577,7 +5577,7 @@
           <p:nvPr/>
         </p:nvPicPr>
         <p:blipFill>
-          <a:blip xmlns:r="http://schemas.openxmlformats.org/officeDocument/2006/relationships" xmlns:a="http://schemas.openxmlformats.org/drawingml/2006/main" r:embed="R2a3e17474b324b45"/>
+          <a:blip xmlns:r="http://schemas.openxmlformats.org/officeDocument/2006/relationships" xmlns:a="http://schemas.openxmlformats.org/drawingml/2006/main" r:embed="R6fa863da010d4e4a"/>
           <a:stretch xmlns:a="http://schemas.openxmlformats.org/drawingml/2006/main">
             <a:fillRect l="0" t="0" r="0" b="0"/>
           </a:stretch>
@@ -5726,7 +5726,7 @@
           <p:nvPr/>
         </p:nvPicPr>
         <p:blipFill>
-          <a:blip xmlns:r="http://schemas.openxmlformats.org/officeDocument/2006/relationships" xmlns:a="http://schemas.openxmlformats.org/drawingml/2006/main" r:embed="Rf37f419876d5411b"/>
+          <a:blip xmlns:r="http://schemas.openxmlformats.org/officeDocument/2006/relationships" xmlns:a="http://schemas.openxmlformats.org/drawingml/2006/main" r:embed="Re9a08b2588474246"/>
           <a:stretch xmlns:a="http://schemas.openxmlformats.org/drawingml/2006/main">
             <a:fillRect l="0" t="0" r="0" b="0"/>
           </a:stretch>
@@ -5880,7 +5880,7 @@
           <p:nvPr/>
         </p:nvPicPr>
         <p:blipFill>
-          <a:blip xmlns:r="http://schemas.openxmlformats.org/officeDocument/2006/relationships" xmlns:a="http://schemas.openxmlformats.org/drawingml/2006/main" r:embed="R2bf061a8248b414f"/>
+          <a:blip xmlns:r="http://schemas.openxmlformats.org/officeDocument/2006/relationships" xmlns:a="http://schemas.openxmlformats.org/drawingml/2006/main" r:embed="Rd991831accc246d4"/>
           <a:stretch xmlns:a="http://schemas.openxmlformats.org/drawingml/2006/main">
             <a:fillRect l="0" t="0" r="0" b="0"/>
           </a:stretch>
@@ -6029,7 +6029,7 @@
           <p:nvPr/>
         </p:nvPicPr>
         <p:blipFill>
-          <a:blip xmlns:r="http://schemas.openxmlformats.org/officeDocument/2006/relationships" xmlns:a="http://schemas.openxmlformats.org/drawingml/2006/main" r:embed="Rae5928f381ed4708"/>
+          <a:blip xmlns:r="http://schemas.openxmlformats.org/officeDocument/2006/relationships" xmlns:a="http://schemas.openxmlformats.org/drawingml/2006/main" r:embed="R075d4a226cd84460"/>
           <a:stretch xmlns:a="http://schemas.openxmlformats.org/drawingml/2006/main">
             <a:fillRect l="0" t="0" r="0" b="0"/>
           </a:stretch>
@@ -6183,7 +6183,7 @@
           <p:nvPr/>
         </p:nvPicPr>
         <p:blipFill>
-          <a:blip xmlns:r="http://schemas.openxmlformats.org/officeDocument/2006/relationships" xmlns:a="http://schemas.openxmlformats.org/drawingml/2006/main" r:embed="Rd1ebe8f62d1249ee"/>
+          <a:blip xmlns:r="http://schemas.openxmlformats.org/officeDocument/2006/relationships" xmlns:a="http://schemas.openxmlformats.org/drawingml/2006/main" r:embed="R4001d22a1ec54330"/>
           <a:stretch xmlns:a="http://schemas.openxmlformats.org/drawingml/2006/main">
             <a:fillRect l="0" t="0" r="0" b="0"/>
           </a:stretch>
@@ -6332,7 +6332,7 @@
           <p:nvPr/>
         </p:nvPicPr>
         <p:blipFill>
-          <a:blip xmlns:r="http://schemas.openxmlformats.org/officeDocument/2006/relationships" xmlns:a="http://schemas.openxmlformats.org/drawingml/2006/main" r:embed="R79f332e103904b1d"/>
+          <a:blip xmlns:r="http://schemas.openxmlformats.org/officeDocument/2006/relationships" xmlns:a="http://schemas.openxmlformats.org/drawingml/2006/main" r:embed="R3ff99103c1d34823"/>
           <a:stretch xmlns:a="http://schemas.openxmlformats.org/drawingml/2006/main">
             <a:fillRect l="0" t="0" r="0" b="0"/>
           </a:stretch>
@@ -6481,7 +6481,7 @@
           <p:nvPr/>
         </p:nvPicPr>
         <p:blipFill>
-          <a:blip xmlns:r="http://schemas.openxmlformats.org/officeDocument/2006/relationships" xmlns:a="http://schemas.openxmlformats.org/drawingml/2006/main" r:embed="Rc1f1fbd8a7344821"/>
+          <a:blip xmlns:r="http://schemas.openxmlformats.org/officeDocument/2006/relationships" xmlns:a="http://schemas.openxmlformats.org/drawingml/2006/main" r:embed="R46754e8fcdae484b"/>
           <a:stretch xmlns:a="http://schemas.openxmlformats.org/drawingml/2006/main">
             <a:fillRect l="0" t="0" r="0" b="0"/>
           </a:stretch>
@@ -6630,7 +6630,7 @@
           <p:nvPr/>
         </p:nvPicPr>
         <p:blipFill>
-          <a:blip xmlns:r="http://schemas.openxmlformats.org/officeDocument/2006/relationships" xmlns:a="http://schemas.openxmlformats.org/drawingml/2006/main" r:embed="R4f5c685bd93c477d"/>
+          <a:blip xmlns:r="http://schemas.openxmlformats.org/officeDocument/2006/relationships" xmlns:a="http://schemas.openxmlformats.org/drawingml/2006/main" r:embed="Re85cbd7d16084b42"/>
           <a:stretch xmlns:a="http://schemas.openxmlformats.org/drawingml/2006/main">
             <a:fillRect l="0" t="0" r="0" b="0"/>
           </a:stretch>
@@ -6779,7 +6779,7 @@
           <p:nvPr/>
         </p:nvPicPr>
         <p:blipFill>
-          <a:blip xmlns:r="http://schemas.openxmlformats.org/officeDocument/2006/relationships" xmlns:a="http://schemas.openxmlformats.org/drawingml/2006/main" r:embed="R834dede8216f42af"/>
+          <a:blip xmlns:r="http://schemas.openxmlformats.org/officeDocument/2006/relationships" xmlns:a="http://schemas.openxmlformats.org/drawingml/2006/main" r:embed="Rb0c80f6c6ee944ab"/>
           <a:stretch xmlns:a="http://schemas.openxmlformats.org/drawingml/2006/main">
             <a:fillRect l="0" t="0" r="0" b="0"/>
           </a:stretch>
@@ -7047,7 +7047,29 @@
                 <a:ea typeface="Calibri"/>
                 <a:cs typeface="Calibri"/>
               </a:rPr>
-              <a:t>Already closed: no E-stop (vending machine) · table-door actuator out of scope · MAINCTRL and DOORIO are off-the-shelf boards.</a:t>
+              <a:t>Already closed: no E-stop (vending machine) · table-door actuator out of scope · MAINCTRL and </a:t>
+            </a:r>
+            <a:r>
+              <a:rPr sz="1400">
+                <a:solidFill>
+                  <a:srgbClr val="6B7480"/>
+                </a:solidFill>
+                <a:latin typeface="Calibri"/>
+                <a:ea typeface="Calibri"/>
+                <a:cs typeface="Calibri"/>
+              </a:rPr>
+              <a:t>IOCTRL</a:t>
+            </a:r>
+            <a:r>
+              <a:rPr sz="1400">
+                <a:solidFill>
+                  <a:srgbClr val="6B7480"/>
+                </a:solidFill>
+                <a:latin typeface="Calibri"/>
+                <a:ea typeface="Calibri"/>
+                <a:cs typeface="Calibri"/>
+              </a:rPr>
+              <a:t> are off-the-shelf boards.</a:t>
             </a:r>
             <a:endParaRPr sz="1400"/>
           </a:p>
@@ -7130,7 +7152,7 @@
           <p:nvPr/>
         </p:nvPicPr>
         <p:blipFill>
-          <a:blip xmlns:r="http://schemas.openxmlformats.org/officeDocument/2006/relationships" xmlns:a="http://schemas.openxmlformats.org/drawingml/2006/main" r:embed="R6e67e7ba07d64a53"/>
+          <a:blip xmlns:r="http://schemas.openxmlformats.org/officeDocument/2006/relationships" xmlns:a="http://schemas.openxmlformats.org/drawingml/2006/main" r:embed="R76b8cc27f4324683"/>
           <a:stretch xmlns:a="http://schemas.openxmlformats.org/drawingml/2006/main">
             <a:fillRect l="0" t="0" r="0" b="0"/>
           </a:stretch>
@@ -7314,7 +7336,7 @@
           <p:nvPr/>
         </p:nvPicPr>
         <p:blipFill>
-          <a:blip xmlns:r="http://schemas.openxmlformats.org/officeDocument/2006/relationships" xmlns:a="http://schemas.openxmlformats.org/drawingml/2006/main" r:embed="Rfe43ee6d15764be0"/>
+          <a:blip xmlns:r="http://schemas.openxmlformats.org/officeDocument/2006/relationships" xmlns:a="http://schemas.openxmlformats.org/drawingml/2006/main" r:embed="Rdd273d0a59eb4ad3"/>
           <a:stretch xmlns:a="http://schemas.openxmlformats.org/drawingml/2006/main">
             <a:fillRect l="0" t="0" r="0" b="0"/>
           </a:stretch>
@@ -7498,7 +7520,7 @@
           <p:nvPr/>
         </p:nvPicPr>
         <p:blipFill>
-          <a:blip xmlns:r="http://schemas.openxmlformats.org/officeDocument/2006/relationships" xmlns:a="http://schemas.openxmlformats.org/drawingml/2006/main" r:embed="Rbe86047761c44c60"/>
+          <a:blip xmlns:r="http://schemas.openxmlformats.org/officeDocument/2006/relationships" xmlns:a="http://schemas.openxmlformats.org/drawingml/2006/main" r:embed="R5939e9f70f8041a7"/>
           <a:stretch xmlns:a="http://schemas.openxmlformats.org/drawingml/2006/main">
             <a:fillRect l="0" t="0" r="0" b="0"/>
           </a:stretch>
@@ -7687,7 +7709,7 @@
           <p:nvPr/>
         </p:nvPicPr>
         <p:blipFill>
-          <a:blip xmlns:r="http://schemas.openxmlformats.org/officeDocument/2006/relationships" xmlns:a="http://schemas.openxmlformats.org/drawingml/2006/main" r:embed="Re7e17578ed714fef"/>
+          <a:blip xmlns:r="http://schemas.openxmlformats.org/officeDocument/2006/relationships" xmlns:a="http://schemas.openxmlformats.org/drawingml/2006/main" r:embed="R63de8c047f6948e7"/>
           <a:stretch xmlns:a="http://schemas.openxmlformats.org/drawingml/2006/main">
             <a:fillRect l="0" t="0" r="0" b="0"/>
           </a:stretch>
@@ -7871,7 +7893,7 @@
           <p:nvPr/>
         </p:nvPicPr>
         <p:blipFill>
-          <a:blip xmlns:r="http://schemas.openxmlformats.org/officeDocument/2006/relationships" xmlns:a="http://schemas.openxmlformats.org/drawingml/2006/main" r:embed="R2c5a3db2c0294f47"/>
+          <a:blip xmlns:r="http://schemas.openxmlformats.org/officeDocument/2006/relationships" xmlns:a="http://schemas.openxmlformats.org/drawingml/2006/main" r:embed="R4233c6aede9c4034"/>
           <a:stretch xmlns:a="http://schemas.openxmlformats.org/drawingml/2006/main">
             <a:fillRect l="0" t="0" r="0" b="0"/>
           </a:stretch>
@@ -8060,7 +8082,7 @@
           <p:nvPr/>
         </p:nvPicPr>
         <p:blipFill>
-          <a:blip xmlns:r="http://schemas.openxmlformats.org/officeDocument/2006/relationships" xmlns:a="http://schemas.openxmlformats.org/drawingml/2006/main" r:embed="R95a724fa6ced4ae5"/>
+          <a:blip xmlns:r="http://schemas.openxmlformats.org/officeDocument/2006/relationships" xmlns:a="http://schemas.openxmlformats.org/drawingml/2006/main" r:embed="R712421b76c444dca"/>
           <a:stretch xmlns:a="http://schemas.openxmlformats.org/drawingml/2006/main">
             <a:fillRect l="0" t="0" r="0" b="0"/>
           </a:stretch>
@@ -8244,7 +8266,7 @@
           <p:nvPr/>
         </p:nvPicPr>
         <p:blipFill>
-          <a:blip xmlns:r="http://schemas.openxmlformats.org/officeDocument/2006/relationships" xmlns:a="http://schemas.openxmlformats.org/drawingml/2006/main" r:embed="R3ce77bded90e48ff"/>
+          <a:blip xmlns:r="http://schemas.openxmlformats.org/officeDocument/2006/relationships" xmlns:a="http://schemas.openxmlformats.org/drawingml/2006/main" r:embed="R89891dc9a3e54604"/>
           <a:stretch xmlns:a="http://schemas.openxmlformats.org/drawingml/2006/main">
             <a:fillRect l="0" t="0" r="0" b="0"/>
           </a:stretch>
@@ -8428,7 +8450,7 @@
           <p:nvPr/>
         </p:nvPicPr>
         <p:blipFill>
-          <a:blip xmlns:r="http://schemas.openxmlformats.org/officeDocument/2006/relationships" xmlns:a="http://schemas.openxmlformats.org/drawingml/2006/main" r:embed="R5c3f0f8dec42403f"/>
+          <a:blip xmlns:r="http://schemas.openxmlformats.org/officeDocument/2006/relationships" xmlns:a="http://schemas.openxmlformats.org/drawingml/2006/main" r:embed="Rcb91fd99be364b44"/>
           <a:stretch xmlns:a="http://schemas.openxmlformats.org/drawingml/2006/main">
             <a:fillRect l="0" t="0" r="0" b="0"/>
           </a:stretch>
@@ -8612,7 +8634,7 @@
           <p:nvPr/>
         </p:nvPicPr>
         <p:blipFill>
-          <a:blip xmlns:r="http://schemas.openxmlformats.org/officeDocument/2006/relationships" xmlns:a="http://schemas.openxmlformats.org/drawingml/2006/main" r:embed="R6a1f5b0772ef47b1"/>
+          <a:blip xmlns:r="http://schemas.openxmlformats.org/officeDocument/2006/relationships" xmlns:a="http://schemas.openxmlformats.org/drawingml/2006/main" r:embed="R7c526dea5d264404"/>
           <a:stretch xmlns:a="http://schemas.openxmlformats.org/drawingml/2006/main">
             <a:fillRect l="0" t="0" r="0" b="0"/>
           </a:stretch>
@@ -8796,7 +8818,7 @@
           <p:nvPr/>
         </p:nvPicPr>
         <p:blipFill>
-          <a:blip xmlns:r="http://schemas.openxmlformats.org/officeDocument/2006/relationships" xmlns:a="http://schemas.openxmlformats.org/drawingml/2006/main" r:embed="R9de35aa5394249ee"/>
+          <a:blip xmlns:r="http://schemas.openxmlformats.org/officeDocument/2006/relationships" xmlns:a="http://schemas.openxmlformats.org/drawingml/2006/main" r:embed="R6f4bf7d0a7984201"/>
           <a:stretch xmlns:a="http://schemas.openxmlformats.org/drawingml/2006/main">
             <a:fillRect l="0" t="0" r="0" b="0"/>
           </a:stretch>
@@ -9496,7 +9518,18 @@
                 <a:ea typeface="Calibri"/>
                 <a:cs typeface="Calibri"/>
               </a:rPr>
-              <a:t>MAINCTRL · DOORIO</a:t>
+              <a:t>MAINCTRL · </a:t>
+            </a:r>
+            <a:r>
+              <a:rPr sz="1100">
+                <a:solidFill>
+                  <a:srgbClr val="CADCFC"/>
+                </a:solidFill>
+                <a:latin typeface="Calibri"/>
+                <a:ea typeface="Calibri"/>
+                <a:cs typeface="Calibri"/>
+              </a:rPr>
+              <a:t>IOCTRL</a:t>
             </a:r>
             <a:endParaRPr sz="1100"/>
           </a:p>
@@ -9688,7 +9721,7 @@
           <p:nvPr/>
         </p:nvPicPr>
         <p:blipFill>
-          <a:blip xmlns:r="http://schemas.openxmlformats.org/officeDocument/2006/relationships" xmlns:a="http://schemas.openxmlformats.org/drawingml/2006/main" r:embed="Raaeb476b89e244b8"/>
+          <a:blip xmlns:r="http://schemas.openxmlformats.org/officeDocument/2006/relationships" xmlns:a="http://schemas.openxmlformats.org/drawingml/2006/main" r:embed="Rf6a3274e78b94346"/>
           <a:stretch xmlns:a="http://schemas.openxmlformats.org/drawingml/2006/main">
             <a:fillRect l="0" t="0" r="0" b="0"/>
           </a:stretch>
@@ -9789,7 +9822,29 @@
                 <a:ea typeface="Calibri"/>
                 <a:cs typeface="Calibri"/>
               </a:rPr>
-              <a:t>MAINCTRL = COTS MYIR MYD-YF13X (STM32MP135, Linux) · SYSCTRL custom STM32 (gantry + labeling) · DOORIO = COTS relay / IO module on RS485 · LANECTRL ×10 custom, our design, with the lane buttons and LEDs on the board.</a:t>
+              <a:t>MAINCTRL = COTS MYIR MYD-YF13X (STM32MP135, Linux) · SYSCTRL custom STM32 (gantry + labeling) · </a:t>
+            </a:r>
+            <a:r>
+              <a:rPr sz="1100">
+                <a:solidFill>
+                  <a:srgbClr val="1A1F24"/>
+                </a:solidFill>
+                <a:latin typeface="Calibri"/>
+                <a:ea typeface="Calibri"/>
+                <a:cs typeface="Calibri"/>
+              </a:rPr>
+              <a:t>IOCTRL</a:t>
+            </a:r>
+            <a:r>
+              <a:rPr sz="1100">
+                <a:solidFill>
+                  <a:srgbClr val="1A1F24"/>
+                </a:solidFill>
+                <a:latin typeface="Calibri"/>
+                <a:ea typeface="Calibri"/>
+                <a:cs typeface="Calibri"/>
+              </a:rPr>
+              <a:t> = COTS relay / IO module on RS485 · LANECTRL ×10 custom, our design, with the lane buttons and LEDs on the board.</a:t>
             </a:r>
             <a:endParaRPr sz="1100"/>
           </a:p>
@@ -9837,7 +9892,7 @@
           <p:nvPr/>
         </p:nvPicPr>
         <p:blipFill>
-          <a:blip xmlns:r="http://schemas.openxmlformats.org/officeDocument/2006/relationships" xmlns:a="http://schemas.openxmlformats.org/drawingml/2006/main" r:embed="R7d4a6f40cad944c2"/>
+          <a:blip xmlns:r="http://schemas.openxmlformats.org/officeDocument/2006/relationships" xmlns:a="http://schemas.openxmlformats.org/drawingml/2006/main" r:embed="R713e257c794c4e6d"/>
           <a:stretch xmlns:a="http://schemas.openxmlformats.org/drawingml/2006/main">
             <a:fillRect l="0" t="0" r="0" b="0"/>
           </a:stretch>
@@ -9986,7 +10041,7 @@
           <p:nvPr/>
         </p:nvPicPr>
         <p:blipFill>
-          <a:blip xmlns:r="http://schemas.openxmlformats.org/officeDocument/2006/relationships" xmlns:a="http://schemas.openxmlformats.org/drawingml/2006/main" r:embed="Rb616de6bfc674277"/>
+          <a:blip xmlns:r="http://schemas.openxmlformats.org/officeDocument/2006/relationships" xmlns:a="http://schemas.openxmlformats.org/drawingml/2006/main" r:embed="Re471d80dfe654ad8"/>
           <a:stretch xmlns:a="http://schemas.openxmlformats.org/drawingml/2006/main">
             <a:fillRect l="0" t="0" r="0" b="0"/>
           </a:stretch>
@@ -10087,7 +10142,29 @@
                 <a:ea typeface="Calibri"/>
                 <a:cs typeface="Calibri"/>
               </a:rPr>
-              <a:t>CAN backbone to SYSCTRL and the 10 lane rows · RS485 to DOORIO · Ethernet / Wi-Fi to the site.</a:t>
+              <a:t>CAN backbone to SYSCTRL and the 10 lane rows · RS485 to </a:t>
+            </a:r>
+            <a:r>
+              <a:rPr sz="1100">
+                <a:solidFill>
+                  <a:srgbClr val="1A1F24"/>
+                </a:solidFill>
+                <a:latin typeface="Calibri"/>
+                <a:ea typeface="Calibri"/>
+                <a:cs typeface="Calibri"/>
+              </a:rPr>
+              <a:t>IOCTRL</a:t>
+            </a:r>
+            <a:r>
+              <a:rPr sz="1100">
+                <a:solidFill>
+                  <a:srgbClr val="1A1F24"/>
+                </a:solidFill>
+                <a:latin typeface="Calibri"/>
+                <a:ea typeface="Calibri"/>
+                <a:cs typeface="Calibri"/>
+              </a:rPr>
+              <a:t> · Ethernet / Wi-Fi to the site.</a:t>
             </a:r>
             <a:endParaRPr sz="1100"/>
           </a:p>
@@ -10135,7 +10212,7 @@
           <p:nvPr/>
         </p:nvPicPr>
         <p:blipFill>
-          <a:blip xmlns:r="http://schemas.openxmlformats.org/officeDocument/2006/relationships" xmlns:a="http://schemas.openxmlformats.org/drawingml/2006/main" r:embed="R392a1d6bf8f941c5"/>
+          <a:blip xmlns:r="http://schemas.openxmlformats.org/officeDocument/2006/relationships" xmlns:a="http://schemas.openxmlformats.org/drawingml/2006/main" r:embed="R84fd1c9b921c477e"/>
           <a:stretch xmlns:a="http://schemas.openxmlformats.org/drawingml/2006/main">
             <a:fillRect l="0" t="0" r="0" b="0"/>
           </a:stretch>
@@ -10251,8 +10328,8 @@
           <p:nvPr/>
         </p:nvPicPr>
         <p:blipFill>
-          <a:blip xmlns:r="http://schemas.openxmlformats.org/officeDocument/2006/relationships" xmlns:a="http://schemas.openxmlformats.org/drawingml/2006/main" r:embed="R236343a71f5742b2"/>
-          <a:srcRect xmlns:a="http://schemas.openxmlformats.org/drawingml/2006/main" l="1719" t="0" r="1719" b="0"/>
+          <a:blip xmlns:r="http://schemas.openxmlformats.org/officeDocument/2006/relationships" xmlns:a="http://schemas.openxmlformats.org/drawingml/2006/main" r:embed="R9a926d043fcf456e"/>
+          <a:srcRect xmlns:a="http://schemas.openxmlformats.org/drawingml/2006/main" l="2473" t="0" r="2473" b="0"/>
           <a:stretch xmlns:a="http://schemas.openxmlformats.org/drawingml/2006/main">
             <a:fillRect l="0" t="0" r="0" b="0"/>
           </a:stretch>
@@ -10322,7 +10399,7 @@
           <p:nvPr/>
         </p:nvPicPr>
         <p:blipFill>
-          <a:blip xmlns:r="http://schemas.openxmlformats.org/officeDocument/2006/relationships" xmlns:a="http://schemas.openxmlformats.org/drawingml/2006/main" r:embed="R20d9c4e0b2cf4585"/>
+          <a:blip xmlns:r="http://schemas.openxmlformats.org/officeDocument/2006/relationships" xmlns:a="http://schemas.openxmlformats.org/drawingml/2006/main" r:embed="R9e43e99c4b824f88"/>
           <a:stretch xmlns:a="http://schemas.openxmlformats.org/drawingml/2006/main">
             <a:fillRect l="0" t="0" r="0" b="0"/>
           </a:stretch>
@@ -10546,7 +10623,7 @@
           <p:nvPr/>
         </p:nvPicPr>
         <p:blipFill>
-          <a:blip xmlns:r="http://schemas.openxmlformats.org/officeDocument/2006/relationships" xmlns:a="http://schemas.openxmlformats.org/drawingml/2006/main" r:embed="R9e6f94465f1248a4"/>
+          <a:blip xmlns:r="http://schemas.openxmlformats.org/officeDocument/2006/relationships" xmlns:a="http://schemas.openxmlformats.org/drawingml/2006/main" r:embed="R618ac6c759044938"/>
           <a:stretch xmlns:a="http://schemas.openxmlformats.org/drawingml/2006/main">
             <a:fillRect l="0" t="0" r="0" b="0"/>
           </a:stretch>
@@ -10662,7 +10739,7 @@
           <p:nvPr/>
         </p:nvPicPr>
         <p:blipFill>
-          <a:blip xmlns:r="http://schemas.openxmlformats.org/officeDocument/2006/relationships" xmlns:a="http://schemas.openxmlformats.org/drawingml/2006/main" r:embed="Rc0b2592cd1094c24"/>
+          <a:blip xmlns:r="http://schemas.openxmlformats.org/officeDocument/2006/relationships" xmlns:a="http://schemas.openxmlformats.org/drawingml/2006/main" r:embed="R33e608722e4b43ff"/>
           <a:stretch xmlns:a="http://schemas.openxmlformats.org/drawingml/2006/main">
             <a:fillRect l="0" t="0" r="0" b="0"/>
           </a:stretch>
@@ -10892,7 +10969,7 @@
           <p:nvPr/>
         </p:nvPicPr>
         <p:blipFill>
-          <a:blip xmlns:r="http://schemas.openxmlformats.org/officeDocument/2006/relationships" xmlns:a="http://schemas.openxmlformats.org/drawingml/2006/main" r:embed="R2746ca9a75134fd8"/>
+          <a:blip xmlns:r="http://schemas.openxmlformats.org/officeDocument/2006/relationships" xmlns:a="http://schemas.openxmlformats.org/drawingml/2006/main" r:embed="Ra416c98fb0d34eeb"/>
           <a:stretch xmlns:a="http://schemas.openxmlformats.org/drawingml/2006/main">
             <a:fillRect l="0" t="0" r="0" b="0"/>
           </a:stretch>
@@ -11279,7 +11356,7 @@
           <p:nvPr/>
         </p:nvPicPr>
         <p:blipFill>
-          <a:blip xmlns:r="http://schemas.openxmlformats.org/officeDocument/2006/relationships" xmlns:a="http://schemas.openxmlformats.org/drawingml/2006/main" r:embed="Rca8adb08a2234524"/>
+          <a:blip xmlns:r="http://schemas.openxmlformats.org/officeDocument/2006/relationships" xmlns:a="http://schemas.openxmlformats.org/drawingml/2006/main" r:embed="R82a17682c7c746a2"/>
           <a:stretch xmlns:a="http://schemas.openxmlformats.org/drawingml/2006/main">
             <a:fillRect l="0" t="0" r="0" b="0"/>
           </a:stretch>
@@ -11395,7 +11472,7 @@
           <p:nvPr/>
         </p:nvPicPr>
         <p:blipFill>
-          <a:blip xmlns:r="http://schemas.openxmlformats.org/officeDocument/2006/relationships" xmlns:a="http://schemas.openxmlformats.org/drawingml/2006/main" r:embed="R5559060d14c04e7c"/>
+          <a:blip xmlns:r="http://schemas.openxmlformats.org/officeDocument/2006/relationships" xmlns:a="http://schemas.openxmlformats.org/drawingml/2006/main" r:embed="R7f74ea82ecef4534"/>
           <a:srcRect xmlns:a="http://schemas.openxmlformats.org/drawingml/2006/main" l="0" t="169" r="0" b="169"/>
           <a:stretch xmlns:a="http://schemas.openxmlformats.org/drawingml/2006/main">
             <a:fillRect l="0" t="0" r="0" b="0"/>
@@ -11626,7 +11703,7 @@
           <p:nvPr/>
         </p:nvPicPr>
         <p:blipFill>
-          <a:blip xmlns:r="http://schemas.openxmlformats.org/officeDocument/2006/relationships" xmlns:a="http://schemas.openxmlformats.org/drawingml/2006/main" r:embed="Rccf3529cd9a6446b"/>
+          <a:blip xmlns:r="http://schemas.openxmlformats.org/officeDocument/2006/relationships" xmlns:a="http://schemas.openxmlformats.org/drawingml/2006/main" r:embed="Rd29b3b83a9e5412e"/>
           <a:stretch xmlns:a="http://schemas.openxmlformats.org/drawingml/2006/main">
             <a:fillRect l="0" t="0" r="0" b="0"/>
           </a:stretch>
@@ -12013,7 +12090,7 @@
           <p:nvPr/>
         </p:nvPicPr>
         <p:blipFill>
-          <a:blip xmlns:r="http://schemas.openxmlformats.org/officeDocument/2006/relationships" xmlns:a="http://schemas.openxmlformats.org/drawingml/2006/main" r:embed="R5564156505214e10"/>
+          <a:blip xmlns:r="http://schemas.openxmlformats.org/officeDocument/2006/relationships" xmlns:a="http://schemas.openxmlformats.org/drawingml/2006/main" r:embed="Rc127e786a11245be"/>
           <a:stretch xmlns:a="http://schemas.openxmlformats.org/drawingml/2006/main">
             <a:fillRect l="0" t="0" r="0" b="0"/>
           </a:stretch>
@@ -12129,7 +12206,7 @@
           <p:nvPr/>
         </p:nvPicPr>
         <p:blipFill>
-          <a:blip xmlns:r="http://schemas.openxmlformats.org/officeDocument/2006/relationships" xmlns:a="http://schemas.openxmlformats.org/drawingml/2006/main" r:embed="Re72cc8b2c43a4f7e"/>
+          <a:blip xmlns:r="http://schemas.openxmlformats.org/officeDocument/2006/relationships" xmlns:a="http://schemas.openxmlformats.org/drawingml/2006/main" r:embed="Rc8fe97a841f242a3"/>
           <a:stretch xmlns:a="http://schemas.openxmlformats.org/drawingml/2006/main">
             <a:fillRect l="0" t="0" r="0" b="0"/>
           </a:stretch>
@@ -12364,7 +12441,7 @@
           <p:nvPr/>
         </p:nvPicPr>
         <p:blipFill>
-          <a:blip xmlns:r="http://schemas.openxmlformats.org/officeDocument/2006/relationships" xmlns:a="http://schemas.openxmlformats.org/drawingml/2006/main" r:embed="R44c10ec3877d4596"/>
+          <a:blip xmlns:r="http://schemas.openxmlformats.org/officeDocument/2006/relationships" xmlns:a="http://schemas.openxmlformats.org/drawingml/2006/main" r:embed="Rb6f1fc44aa854fb3"/>
           <a:stretch xmlns:a="http://schemas.openxmlformats.org/drawingml/2006/main">
             <a:fillRect l="0" t="0" r="0" b="0"/>
           </a:stretch>
@@ -12749,7 +12826,7 @@
           <p:nvPr/>
         </p:nvPicPr>
         <p:blipFill>
-          <a:blip xmlns:r="http://schemas.openxmlformats.org/officeDocument/2006/relationships" xmlns:a="http://schemas.openxmlformats.org/drawingml/2006/main" r:embed="R4cdd1f78f042451a"/>
+          <a:blip xmlns:r="http://schemas.openxmlformats.org/officeDocument/2006/relationships" xmlns:a="http://schemas.openxmlformats.org/drawingml/2006/main" r:embed="Racaca8b9799f48b8"/>
           <a:stretch xmlns:a="http://schemas.openxmlformats.org/drawingml/2006/main">
             <a:fillRect l="0" t="0" r="0" b="0"/>
           </a:stretch>
@@ -12865,7 +12942,7 @@
           <p:nvPr/>
         </p:nvPicPr>
         <p:blipFill>
-          <a:blip xmlns:r="http://schemas.openxmlformats.org/officeDocument/2006/relationships" xmlns:a="http://schemas.openxmlformats.org/drawingml/2006/main" r:embed="Re2adbf86e6444357"/>
+          <a:blip xmlns:r="http://schemas.openxmlformats.org/officeDocument/2006/relationships" xmlns:a="http://schemas.openxmlformats.org/drawingml/2006/main" r:embed="R4bacaba80d274d66"/>
           <a:srcRect xmlns:a="http://schemas.openxmlformats.org/drawingml/2006/main" l="0" t="169" r="0" b="169"/>
           <a:stretch xmlns:a="http://schemas.openxmlformats.org/drawingml/2006/main">
             <a:fillRect l="0" t="0" r="0" b="0"/>
@@ -13096,7 +13173,7 @@
           <p:nvPr/>
         </p:nvPicPr>
         <p:blipFill>
-          <a:blip xmlns:r="http://schemas.openxmlformats.org/officeDocument/2006/relationships" xmlns:a="http://schemas.openxmlformats.org/drawingml/2006/main" r:embed="R8e0dd02c307d43c4"/>
+          <a:blip xmlns:r="http://schemas.openxmlformats.org/officeDocument/2006/relationships" xmlns:a="http://schemas.openxmlformats.org/drawingml/2006/main" r:embed="R7129029d0feb4932"/>
           <a:stretch xmlns:a="http://schemas.openxmlformats.org/drawingml/2006/main">
             <a:fillRect l="0" t="0" r="0" b="0"/>
           </a:stretch>
@@ -13483,7 +13560,7 @@
           <p:nvPr/>
         </p:nvPicPr>
         <p:blipFill>
-          <a:blip xmlns:r="http://schemas.openxmlformats.org/officeDocument/2006/relationships" xmlns:a="http://schemas.openxmlformats.org/drawingml/2006/main" r:embed="R048ef96ca57a479c"/>
+          <a:blip xmlns:r="http://schemas.openxmlformats.org/officeDocument/2006/relationships" xmlns:a="http://schemas.openxmlformats.org/drawingml/2006/main" r:embed="R586686b936c84f7c"/>
           <a:stretch xmlns:a="http://schemas.openxmlformats.org/drawingml/2006/main">
             <a:fillRect l="0" t="0" r="0" b="0"/>
           </a:stretch>
@@ -13599,7 +13676,7 @@
           <p:nvPr/>
         </p:nvPicPr>
         <p:blipFill>
-          <a:blip xmlns:r="http://schemas.openxmlformats.org/officeDocument/2006/relationships" xmlns:a="http://schemas.openxmlformats.org/drawingml/2006/main" r:embed="R8003039740e9451f"/>
+          <a:blip xmlns:r="http://schemas.openxmlformats.org/officeDocument/2006/relationships" xmlns:a="http://schemas.openxmlformats.org/drawingml/2006/main" r:embed="R7695568d6a544f84"/>
           <a:stretch xmlns:a="http://schemas.openxmlformats.org/drawingml/2006/main">
             <a:fillRect l="0" t="0" r="0" b="0"/>
           </a:stretch>
@@ -13829,7 +13906,7 @@
           <p:nvPr/>
         </p:nvPicPr>
         <p:blipFill>
-          <a:blip xmlns:r="http://schemas.openxmlformats.org/officeDocument/2006/relationships" xmlns:a="http://schemas.openxmlformats.org/drawingml/2006/main" r:embed="R43d88ec8f528471e"/>
+          <a:blip xmlns:r="http://schemas.openxmlformats.org/officeDocument/2006/relationships" xmlns:a="http://schemas.openxmlformats.org/drawingml/2006/main" r:embed="R8b154ea7bd0d4070"/>
           <a:stretch xmlns:a="http://schemas.openxmlformats.org/drawingml/2006/main">
             <a:fillRect l="0" t="0" r="0" b="0"/>
           </a:stretch>
@@ -14214,7 +14291,7 @@
           <p:nvPr/>
         </p:nvPicPr>
         <p:blipFill>
-          <a:blip xmlns:r="http://schemas.openxmlformats.org/officeDocument/2006/relationships" xmlns:a="http://schemas.openxmlformats.org/drawingml/2006/main" r:embed="Raa7ccbf4bf14464e"/>
+          <a:blip xmlns:r="http://schemas.openxmlformats.org/officeDocument/2006/relationships" xmlns:a="http://schemas.openxmlformats.org/drawingml/2006/main" r:embed="R74996991e3374fe3"/>
           <a:stretch xmlns:a="http://schemas.openxmlformats.org/drawingml/2006/main">
             <a:fillRect l="0" t="0" r="0" b="0"/>
           </a:stretch>
@@ -14330,7 +14407,7 @@
           <p:nvPr/>
         </p:nvPicPr>
         <p:blipFill>
-          <a:blip xmlns:r="http://schemas.openxmlformats.org/officeDocument/2006/relationships" xmlns:a="http://schemas.openxmlformats.org/drawingml/2006/main" r:embed="R43a15b96fdb64a46"/>
+          <a:blip xmlns:r="http://schemas.openxmlformats.org/officeDocument/2006/relationships" xmlns:a="http://schemas.openxmlformats.org/drawingml/2006/main" r:embed="Rfe870e2a03334357"/>
           <a:stretch xmlns:a="http://schemas.openxmlformats.org/drawingml/2006/main">
             <a:fillRect l="0" t="0" r="0" b="0"/>
           </a:stretch>
@@ -14560,7 +14637,7 @@
           <p:nvPr/>
         </p:nvPicPr>
         <p:blipFill>
-          <a:blip xmlns:r="http://schemas.openxmlformats.org/officeDocument/2006/relationships" xmlns:a="http://schemas.openxmlformats.org/drawingml/2006/main" r:embed="R3d5784660d08428d"/>
+          <a:blip xmlns:r="http://schemas.openxmlformats.org/officeDocument/2006/relationships" xmlns:a="http://schemas.openxmlformats.org/drawingml/2006/main" r:embed="R07ab09cbc37c48ed"/>
           <a:stretch xmlns:a="http://schemas.openxmlformats.org/drawingml/2006/main">
             <a:fillRect l="0" t="0" r="0" b="0"/>
           </a:stretch>

</xml_diff>